<commit_message>
Add live application screenshots to presentation
</commit_message>
<xml_diff>
--- a/docs/GymMembershipLoginSystem-Presentation.pptx
+++ b/docs/GymMembershipLoginSystem-Presentation.pptx
@@ -15,6 +15,8 @@
     <p:sldId id="263" r:id="rId9"/>
     <p:sldId id="264" r:id="rId10"/>
     <p:sldId id="265" r:id="rId11"/>
+    <p:sldId id="269" r:id="rId20"/>
+    <p:sldId id="270" r:id="rId21"/>
     <p:sldId id="266" r:id="rId12"/>
     <p:sldId id="267" r:id="rId13"/>
     <p:sldId id="268" r:id="rId14"/>
@@ -4926,6 +4928,1172 @@
 </p:sld>
 </file>
 
+<file path=ppt/slides/slide14.xml><?xml version="1.0" encoding="utf-8"?>
+<p:sld xmlns:a="http://schemas.openxmlformats.org/drawingml/2006/main" xmlns:p="http://schemas.openxmlformats.org/presentationml/2006/main" xmlns:r="http://schemas.openxmlformats.org/officeDocument/2006/relationships">
+  <p:cSld>
+    <p:spTree>
+      <p:nvGrpSpPr>
+        <p:cNvPr id="1" name=""/>
+        <p:cNvGrpSpPr/>
+        <p:nvPr/>
+      </p:nvGrpSpPr>
+      <p:grpSpPr/>
+      <p:sp>
+        <p:nvSpPr>
+          <p:cNvPr id="2" name="TextBox 1"/>
+          <p:cNvSpPr txBox="1"/>
+          <p:nvPr/>
+        </p:nvSpPr>
+        <p:spPr>
+          <a:xfrm>
+            <a:off x="548640" y="384048"/>
+            <a:ext cx="7315200" cy="274320"/>
+          </a:xfrm>
+          <a:prstGeom prst="rect">
+            <a:avLst/>
+          </a:prstGeom>
+          <a:noFill/>
+        </p:spPr>
+        <p:txBody>
+          <a:bodyPr wrap="none" lIns="0" rIns="0" tIns="0" bIns="0" anchor="ctr">
+            <a:spAutoFit/>
+          </a:bodyPr>
+          <a:lstStyle/>
+          <a:p>
+            <a:r>
+              <a:rPr sz="1100" b="1" spc="200">
+                <a:solidFill>
+                  <a:srgbClr val="5E2CA5"/>
+                </a:solidFill>
+                <a:latin typeface="Calibri"/>
+              </a:rPr>
+              <a:t>APPLICATION IN ACTION</a:t>
+            </a:r>
+          </a:p>
+        </p:txBody>
+      </p:sp>
+      <p:sp>
+        <p:nvSpPr>
+          <p:cNvPr id="3" name="TextBox 2"/>
+          <p:cNvSpPr txBox="1"/>
+          <p:nvPr/>
+        </p:nvSpPr>
+        <p:spPr>
+          <a:xfrm>
+            <a:off x="548640" y="621792"/>
+            <a:ext cx="9601200" cy="640080"/>
+          </a:xfrm>
+          <a:prstGeom prst="rect">
+            <a:avLst/>
+          </a:prstGeom>
+          <a:noFill/>
+        </p:spPr>
+        <p:txBody>
+          <a:bodyPr wrap="none" lIns="0" rIns="0" tIns="0" bIns="0" anchor="ctr">
+            <a:spAutoFit/>
+          </a:bodyPr>
+          <a:lstStyle/>
+          <a:p>
+            <a:r>
+              <a:rPr sz="3000" b="1">
+                <a:solidFill>
+                  <a:srgbClr val="241B33"/>
+                </a:solidFill>
+                <a:latin typeface="Cambria"/>
+              </a:rPr>
+              <a:t>Branded Login &amp; Authentication</a:t>
+            </a:r>
+          </a:p>
+        </p:txBody>
+      </p:sp>
+      <p:sp>
+        <p:nvSpPr>
+          <p:cNvPr id="4" name="Rounded Rectangle 3"/>
+          <p:cNvSpPr/>
+          <p:nvPr/>
+        </p:nvSpPr>
+        <p:spPr>
+          <a:xfrm>
+            <a:off x="548640" y="1554480"/>
+            <a:ext cx="2560320" cy="4343400"/>
+          </a:xfrm>
+          <a:prstGeom prst="roundRect">
+            <a:avLst>
+              <a:gd name="adj" fmla="val 3000"/>
+            </a:avLst>
+          </a:prstGeom>
+          <a:solidFill>
+            <a:srgbClr val="F4F0FB"/>
+          </a:solidFill>
+          <a:ln>
+            <a:noFill/>
+          </a:ln>
+          <a:effectLst>
+            <a:outerShdw sx="100000" sy="100000" kx="0" ky="0" algn="bl" rotWithShape="0" blurRad="76200" dist="25400" dir="5400000">
+              <a:srgbClr val="8A78A8">
+                <a:alpha val="28000"/>
+              </a:srgbClr>
+            </a:outerShdw>
+          </a:effectLst>
+        </p:spPr>
+        <p:style>
+          <a:lnRef idx="1">
+            <a:schemeClr val="accent1"/>
+          </a:lnRef>
+          <a:fillRef idx="3">
+            <a:schemeClr val="accent1"/>
+          </a:fillRef>
+          <a:effectRef idx="2">
+            <a:schemeClr val="accent1"/>
+          </a:effectRef>
+          <a:fontRef idx="minor">
+            <a:schemeClr val="lt1"/>
+          </a:fontRef>
+        </p:style>
+        <p:txBody>
+          <a:bodyPr rtlCol="0" anchor="ctr"/>
+          <a:lstStyle/>
+          <a:p>
+            <a:pPr algn="ctr"/>
+          </a:p>
+        </p:txBody>
+      </p:sp>
+      <p:pic>
+        <p:nvPicPr>
+          <p:cNvPr id="5" name="Picture 4" descr="shot_login.png"/>
+          <p:cNvPicPr>
+            <a:picLocks noChangeAspect="1"/>
+          </p:cNvPicPr>
+          <p:nvPr/>
+        </p:nvPicPr>
+        <p:blipFill>
+          <a:blip r:embed="rId2"/>
+          <a:stretch>
+            <a:fillRect/>
+          </a:stretch>
+        </p:blipFill>
+        <p:spPr>
+          <a:xfrm>
+            <a:off x="731971" y="1691639"/>
+            <a:ext cx="2193657" cy="3566160"/>
+          </a:xfrm>
+          <a:prstGeom prst="rect">
+            <a:avLst/>
+          </a:prstGeom>
+        </p:spPr>
+      </p:pic>
+      <p:sp>
+        <p:nvSpPr>
+          <p:cNvPr id="6" name="TextBox 5"/>
+          <p:cNvSpPr txBox="1"/>
+          <p:nvPr/>
+        </p:nvSpPr>
+        <p:spPr>
+          <a:xfrm>
+            <a:off x="548640" y="5330952"/>
+            <a:ext cx="2560320" cy="320040"/>
+          </a:xfrm>
+          <a:prstGeom prst="rect">
+            <a:avLst/>
+          </a:prstGeom>
+          <a:noFill/>
+        </p:spPr>
+        <p:txBody>
+          <a:bodyPr wrap="none" lIns="0" rIns="0" tIns="0" bIns="0" anchor="ctr">
+            <a:spAutoFit/>
+          </a:bodyPr>
+          <a:lstStyle/>
+          <a:p>
+            <a:pPr algn="ctr"/>
+            <a:r>
+              <a:rPr sz="1100" b="1">
+                <a:solidFill>
+                  <a:srgbClr val="5E2CA5"/>
+                </a:solidFill>
+                <a:latin typeface="Calibri"/>
+              </a:rPr>
+              <a:t>LOGIN SCREEN</a:t>
+            </a:r>
+          </a:p>
+        </p:txBody>
+      </p:sp>
+      <p:sp>
+        <p:nvSpPr>
+          <p:cNvPr id="7" name="Rounded Rectangle 6"/>
+          <p:cNvSpPr/>
+          <p:nvPr/>
+        </p:nvSpPr>
+        <p:spPr>
+          <a:xfrm>
+            <a:off x="3383279" y="1554480"/>
+            <a:ext cx="2560320" cy="4343400"/>
+          </a:xfrm>
+          <a:prstGeom prst="roundRect">
+            <a:avLst>
+              <a:gd name="adj" fmla="val 3000"/>
+            </a:avLst>
+          </a:prstGeom>
+          <a:solidFill>
+            <a:srgbClr val="F4F0FB"/>
+          </a:solidFill>
+          <a:ln>
+            <a:noFill/>
+          </a:ln>
+          <a:effectLst>
+            <a:outerShdw sx="100000" sy="100000" kx="0" ky="0" algn="bl" rotWithShape="0" blurRad="76200" dist="25400" dir="5400000">
+              <a:srgbClr val="8A78A8">
+                <a:alpha val="28000"/>
+              </a:srgbClr>
+            </a:outerShdw>
+          </a:effectLst>
+        </p:spPr>
+        <p:style>
+          <a:lnRef idx="1">
+            <a:schemeClr val="accent1"/>
+          </a:lnRef>
+          <a:fillRef idx="3">
+            <a:schemeClr val="accent1"/>
+          </a:fillRef>
+          <a:effectRef idx="2">
+            <a:schemeClr val="accent1"/>
+          </a:effectRef>
+          <a:fontRef idx="minor">
+            <a:schemeClr val="lt1"/>
+          </a:fontRef>
+        </p:style>
+        <p:txBody>
+          <a:bodyPr rtlCol="0" anchor="ctr"/>
+          <a:lstStyle/>
+          <a:p>
+            <a:pPr algn="ctr"/>
+          </a:p>
+        </p:txBody>
+      </p:sp>
+      <p:pic>
+        <p:nvPicPr>
+          <p:cNvPr id="8" name="Picture 7" descr="shot_login_success.png"/>
+          <p:cNvPicPr>
+            <a:picLocks noChangeAspect="1"/>
+          </p:cNvPicPr>
+          <p:nvPr/>
+        </p:nvPicPr>
+        <p:blipFill>
+          <a:blip r:embed="rId3"/>
+          <a:stretch>
+            <a:fillRect/>
+          </a:stretch>
+        </p:blipFill>
+        <p:spPr>
+          <a:xfrm>
+            <a:off x="3566611" y="1691639"/>
+            <a:ext cx="2193657" cy="3566160"/>
+          </a:xfrm>
+          <a:prstGeom prst="rect">
+            <a:avLst/>
+          </a:prstGeom>
+        </p:spPr>
+      </p:pic>
+      <p:sp>
+        <p:nvSpPr>
+          <p:cNvPr id="9" name="TextBox 8"/>
+          <p:cNvSpPr txBox="1"/>
+          <p:nvPr/>
+        </p:nvSpPr>
+        <p:spPr>
+          <a:xfrm>
+            <a:off x="3383279" y="5330952"/>
+            <a:ext cx="2560320" cy="320040"/>
+          </a:xfrm>
+          <a:prstGeom prst="rect">
+            <a:avLst/>
+          </a:prstGeom>
+          <a:noFill/>
+        </p:spPr>
+        <p:txBody>
+          <a:bodyPr wrap="none" lIns="0" rIns="0" tIns="0" bIns="0" anchor="ctr">
+            <a:spAutoFit/>
+          </a:bodyPr>
+          <a:lstStyle/>
+          <a:p>
+            <a:pPr algn="ctr"/>
+            <a:r>
+              <a:rPr sz="1100" b="1">
+                <a:solidFill>
+                  <a:srgbClr val="5E2CA5"/>
+                </a:solidFill>
+                <a:latin typeface="Calibri"/>
+              </a:rPr>
+              <a:t>SUCCESSFUL AUTHENTICATION</a:t>
+            </a:r>
+          </a:p>
+        </p:txBody>
+      </p:sp>
+      <p:sp>
+        <p:nvSpPr>
+          <p:cNvPr id="10" name="TextBox 9"/>
+          <p:cNvSpPr txBox="1"/>
+          <p:nvPr/>
+        </p:nvSpPr>
+        <p:spPr>
+          <a:xfrm>
+            <a:off x="6035040" y="1600200"/>
+            <a:ext cx="5577840" cy="4480560"/>
+          </a:xfrm>
+          <a:prstGeom prst="rect">
+            <a:avLst/>
+          </a:prstGeom>
+          <a:noFill/>
+        </p:spPr>
+        <p:txBody>
+          <a:bodyPr wrap="square" lIns="0" rIns="0" tIns="0" bIns="0">
+            <a:spAutoFit/>
+          </a:bodyPr>
+          <a:lstStyle/>
+          <a:p>
+            <a:r>
+              <a:rPr sz="1300" b="1">
+                <a:solidFill>
+                  <a:srgbClr val="5E2CA5"/>
+                </a:solidFill>
+                <a:latin typeface="Calibri"/>
+              </a:rPr>
+              <a:t>HOW IT WORKS</a:t>
+            </a:r>
+          </a:p>
+          <a:p>
+            <a:pPr marL="228600" indent="-228600">
+              <a:spcBef>
+                <a:spcPts val="1000"/>
+              </a:spcBef>
+              <a:buFont typeface="Arial"/>
+              <a:buChar char="●"/>
+            </a:pPr>
+            <a:r>
+              <a:rPr sz="1300">
+                <a:solidFill>
+                  <a:srgbClr val="241B33"/>
+                </a:solidFill>
+                <a:latin typeface="Calibri"/>
+              </a:rPr>
+              <a:t>Purple brand theme with a logo drawn at runtime via Graphics2D — no external image asset to manage (UiTheme, GymLogoPanel)</a:t>
+            </a:r>
+          </a:p>
+          <a:p>
+            <a:pPr marL="228600" indent="-228600">
+              <a:spcBef>
+                <a:spcPts val="1000"/>
+              </a:spcBef>
+              <a:buFont typeface="Arial"/>
+              <a:buChar char="●"/>
+            </a:pPr>
+            <a:r>
+              <a:rPr sz="1300">
+                <a:solidFill>
+                  <a:srgbClr val="241B33"/>
+                </a:solidFill>
+                <a:latin typeface="Calibri"/>
+              </a:rPr>
+              <a:t>Credentials verified through AuthenticationController against PBKDF2WithHmacSHA256-hashed passwords (65,536 iterations, random salt) stored in MySQL</a:t>
+            </a:r>
+          </a:p>
+          <a:p>
+            <a:pPr marL="228600" indent="-228600">
+              <a:spcBef>
+                <a:spcPts val="1000"/>
+              </a:spcBef>
+              <a:buFont typeface="Arial"/>
+              <a:buChar char="●"/>
+            </a:pPr>
+            <a:r>
+              <a:rPr sz="1300">
+                <a:solidFill>
+                  <a:srgbClr val="241B33"/>
+                </a:solidFill>
+                <a:latin typeface="Calibri"/>
+              </a:rPr>
+              <a:t>A successful login routes the user to the dashboard matching their role — Admin, Trainer, Receptionist, or Member</a:t>
+            </a:r>
+          </a:p>
+          <a:p>
+            <a:pPr marL="228600" indent="-228600">
+              <a:spcBef>
+                <a:spcPts val="1000"/>
+              </a:spcBef>
+              <a:buFont typeface="Arial"/>
+              <a:buChar char="●"/>
+            </a:pPr>
+            <a:r>
+              <a:rPr sz="1300">
+                <a:solidFill>
+                  <a:srgbClr val="241B33"/>
+                </a:solidFill>
+                <a:latin typeface="Calibri"/>
+              </a:rPr>
+              <a:t>Five consecutive failed attempts trigger a 15-minute account lockout, per SRS 4.2 Robustness</a:t>
+            </a:r>
+          </a:p>
+        </p:txBody>
+      </p:sp>
+    </p:spTree>
+  </p:cSld>
+  <p:clrMapOvr>
+    <a:masterClrMapping/>
+  </p:clrMapOvr>
+</p:sld>
+</file>
+
+<file path=ppt/slides/slide15.xml><?xml version="1.0" encoding="utf-8"?>
+<p:sld xmlns:a="http://schemas.openxmlformats.org/drawingml/2006/main" xmlns:p="http://schemas.openxmlformats.org/presentationml/2006/main" xmlns:r="http://schemas.openxmlformats.org/officeDocument/2006/relationships">
+  <p:cSld>
+    <p:spTree>
+      <p:nvGrpSpPr>
+        <p:cNvPr id="1" name=""/>
+        <p:cNvGrpSpPr/>
+        <p:nvPr/>
+      </p:nvGrpSpPr>
+      <p:grpSpPr/>
+      <p:sp>
+        <p:nvSpPr>
+          <p:cNvPr id="2" name="TextBox 1"/>
+          <p:cNvSpPr txBox="1"/>
+          <p:nvPr/>
+        </p:nvSpPr>
+        <p:spPr>
+          <a:xfrm>
+            <a:off x="548640" y="384048"/>
+            <a:ext cx="7315200" cy="274320"/>
+          </a:xfrm>
+          <a:prstGeom prst="rect">
+            <a:avLst/>
+          </a:prstGeom>
+          <a:noFill/>
+        </p:spPr>
+        <p:txBody>
+          <a:bodyPr wrap="none" lIns="0" rIns="0" tIns="0" bIns="0" anchor="ctr">
+            <a:spAutoFit/>
+          </a:bodyPr>
+          <a:lstStyle/>
+          <a:p>
+            <a:r>
+              <a:rPr sz="1100" b="1" spc="200">
+                <a:solidFill>
+                  <a:srgbClr val="5E2CA5"/>
+                </a:solidFill>
+                <a:latin typeface="Calibri"/>
+              </a:rPr>
+              <a:t>APPLICATION IN ACTION</a:t>
+            </a:r>
+          </a:p>
+        </p:txBody>
+      </p:sp>
+      <p:sp>
+        <p:nvSpPr>
+          <p:cNvPr id="3" name="TextBox 2"/>
+          <p:cNvSpPr txBox="1"/>
+          <p:nvPr/>
+        </p:nvSpPr>
+        <p:spPr>
+          <a:xfrm>
+            <a:off x="548640" y="621792"/>
+            <a:ext cx="9601200" cy="640080"/>
+          </a:xfrm>
+          <a:prstGeom prst="rect">
+            <a:avLst/>
+          </a:prstGeom>
+          <a:noFill/>
+        </p:spPr>
+        <p:txBody>
+          <a:bodyPr wrap="none" lIns="0" rIns="0" tIns="0" bIns="0" anchor="ctr">
+            <a:spAutoFit/>
+          </a:bodyPr>
+          <a:lstStyle/>
+          <a:p>
+            <a:r>
+              <a:rPr sz="3000" b="1">
+                <a:solidFill>
+                  <a:srgbClr val="241B33"/>
+                </a:solidFill>
+                <a:latin typeface="Cambria"/>
+              </a:rPr>
+              <a:t>Core Feature Screens</a:t>
+            </a:r>
+          </a:p>
+        </p:txBody>
+      </p:sp>
+      <p:sp>
+        <p:nvSpPr>
+          <p:cNvPr id="4" name="Rounded Rectangle 3"/>
+          <p:cNvSpPr/>
+          <p:nvPr/>
+        </p:nvSpPr>
+        <p:spPr>
+          <a:xfrm>
+            <a:off x="548640" y="1508760"/>
+            <a:ext cx="3545738" cy="2528316"/>
+          </a:xfrm>
+          <a:prstGeom prst="roundRect">
+            <a:avLst>
+              <a:gd name="adj" fmla="val 4000"/>
+            </a:avLst>
+          </a:prstGeom>
+          <a:solidFill>
+            <a:srgbClr val="F4F0FB"/>
+          </a:solidFill>
+          <a:ln>
+            <a:noFill/>
+          </a:ln>
+          <a:effectLst>
+            <a:outerShdw sx="100000" sy="100000" kx="0" ky="0" algn="bl" rotWithShape="0" blurRad="76200" dist="25400" dir="5400000">
+              <a:srgbClr val="8A78A8">
+                <a:alpha val="28000"/>
+              </a:srgbClr>
+            </a:outerShdw>
+          </a:effectLst>
+        </p:spPr>
+        <p:style>
+          <a:lnRef idx="1">
+            <a:schemeClr val="accent1"/>
+          </a:lnRef>
+          <a:fillRef idx="3">
+            <a:schemeClr val="accent1"/>
+          </a:fillRef>
+          <a:effectRef idx="2">
+            <a:schemeClr val="accent1"/>
+          </a:effectRef>
+          <a:fontRef idx="minor">
+            <a:schemeClr val="lt1"/>
+          </a:fontRef>
+        </p:style>
+        <p:txBody>
+          <a:bodyPr rtlCol="0" anchor="ctr"/>
+          <a:lstStyle/>
+          <a:p>
+            <a:pPr algn="ctr"/>
+          </a:p>
+        </p:txBody>
+      </p:sp>
+      <p:pic>
+        <p:nvPicPr>
+          <p:cNvPr id="5" name="Picture 4" descr="shot_manage_users.png"/>
+          <p:cNvPicPr>
+            <a:picLocks noChangeAspect="1"/>
+          </p:cNvPicPr>
+          <p:nvPr/>
+        </p:nvPicPr>
+        <p:blipFill>
+          <a:blip r:embed="rId2"/>
+          <a:stretch>
+            <a:fillRect/>
+          </a:stretch>
+        </p:blipFill>
+        <p:spPr>
+          <a:xfrm>
+            <a:off x="685799" y="1645920"/>
+            <a:ext cx="3271418" cy="2016299"/>
+          </a:xfrm>
+          <a:prstGeom prst="rect">
+            <a:avLst/>
+          </a:prstGeom>
+        </p:spPr>
+      </p:pic>
+      <p:sp>
+        <p:nvSpPr>
+          <p:cNvPr id="6" name="TextBox 5"/>
+          <p:cNvSpPr txBox="1"/>
+          <p:nvPr/>
+        </p:nvSpPr>
+        <p:spPr>
+          <a:xfrm>
+            <a:off x="548640" y="3753612"/>
+            <a:ext cx="3545738" cy="292608"/>
+          </a:xfrm>
+          <a:prstGeom prst="rect">
+            <a:avLst/>
+          </a:prstGeom>
+          <a:noFill/>
+        </p:spPr>
+        <p:txBody>
+          <a:bodyPr wrap="none" lIns="0" rIns="0" tIns="0" bIns="0" anchor="ctr">
+            <a:spAutoFit/>
+          </a:bodyPr>
+          <a:lstStyle/>
+          <a:p>
+            <a:pPr algn="ctr"/>
+            <a:r>
+              <a:rPr sz="1050" b="1">
+                <a:solidFill>
+                  <a:srgbClr val="5E2CA5"/>
+                </a:solidFill>
+                <a:latin typeface="Calibri"/>
+              </a:rPr>
+              <a:t>MANAGE USERS</a:t>
+            </a:r>
+          </a:p>
+        </p:txBody>
+      </p:sp>
+      <p:sp>
+        <p:nvSpPr>
+          <p:cNvPr id="7" name="Rounded Rectangle 6"/>
+          <p:cNvSpPr/>
+          <p:nvPr/>
+        </p:nvSpPr>
+        <p:spPr>
+          <a:xfrm>
+            <a:off x="4322978" y="1508760"/>
+            <a:ext cx="3545738" cy="2528316"/>
+          </a:xfrm>
+          <a:prstGeom prst="roundRect">
+            <a:avLst>
+              <a:gd name="adj" fmla="val 4000"/>
+            </a:avLst>
+          </a:prstGeom>
+          <a:solidFill>
+            <a:srgbClr val="F4F0FB"/>
+          </a:solidFill>
+          <a:ln>
+            <a:noFill/>
+          </a:ln>
+          <a:effectLst>
+            <a:outerShdw sx="100000" sy="100000" kx="0" ky="0" algn="bl" rotWithShape="0" blurRad="76200" dist="25400" dir="5400000">
+              <a:srgbClr val="8A78A8">
+                <a:alpha val="28000"/>
+              </a:srgbClr>
+            </a:outerShdw>
+          </a:effectLst>
+        </p:spPr>
+        <p:style>
+          <a:lnRef idx="1">
+            <a:schemeClr val="accent1"/>
+          </a:lnRef>
+          <a:fillRef idx="3">
+            <a:schemeClr val="accent1"/>
+          </a:fillRef>
+          <a:effectRef idx="2">
+            <a:schemeClr val="accent1"/>
+          </a:effectRef>
+          <a:fontRef idx="minor">
+            <a:schemeClr val="lt1"/>
+          </a:fontRef>
+        </p:style>
+        <p:txBody>
+          <a:bodyPr rtlCol="0" anchor="ctr"/>
+          <a:lstStyle/>
+          <a:p>
+            <a:pPr algn="ctr"/>
+          </a:p>
+        </p:txBody>
+      </p:sp>
+      <p:pic>
+        <p:nvPicPr>
+          <p:cNvPr id="8" name="Picture 7" descr="shot_membership_plans.png"/>
+          <p:cNvPicPr>
+            <a:picLocks noChangeAspect="1"/>
+          </p:cNvPicPr>
+          <p:nvPr/>
+        </p:nvPicPr>
+        <p:blipFill>
+          <a:blip r:embed="rId3"/>
+          <a:stretch>
+            <a:fillRect/>
+          </a:stretch>
+        </p:blipFill>
+        <p:spPr>
+          <a:xfrm>
+            <a:off x="4739856" y="1645920"/>
+            <a:ext cx="2711982" cy="2034540"/>
+          </a:xfrm>
+          <a:prstGeom prst="rect">
+            <a:avLst/>
+          </a:prstGeom>
+        </p:spPr>
+      </p:pic>
+      <p:sp>
+        <p:nvSpPr>
+          <p:cNvPr id="9" name="TextBox 8"/>
+          <p:cNvSpPr txBox="1"/>
+          <p:nvPr/>
+        </p:nvSpPr>
+        <p:spPr>
+          <a:xfrm>
+            <a:off x="4322978" y="3753612"/>
+            <a:ext cx="3545738" cy="292608"/>
+          </a:xfrm>
+          <a:prstGeom prst="rect">
+            <a:avLst/>
+          </a:prstGeom>
+          <a:noFill/>
+        </p:spPr>
+        <p:txBody>
+          <a:bodyPr wrap="none" lIns="0" rIns="0" tIns="0" bIns="0" anchor="ctr">
+            <a:spAutoFit/>
+          </a:bodyPr>
+          <a:lstStyle/>
+          <a:p>
+            <a:pPr algn="ctr"/>
+            <a:r>
+              <a:rPr sz="1050" b="1">
+                <a:solidFill>
+                  <a:srgbClr val="5E2CA5"/>
+                </a:solidFill>
+                <a:latin typeface="Calibri"/>
+              </a:rPr>
+              <a:t>MEMBERSHIP PLANS</a:t>
+            </a:r>
+          </a:p>
+        </p:txBody>
+      </p:sp>
+      <p:sp>
+        <p:nvSpPr>
+          <p:cNvPr id="10" name="Rounded Rectangle 9"/>
+          <p:cNvSpPr/>
+          <p:nvPr/>
+        </p:nvSpPr>
+        <p:spPr>
+          <a:xfrm>
+            <a:off x="8097316" y="1508760"/>
+            <a:ext cx="3545738" cy="2528316"/>
+          </a:xfrm>
+          <a:prstGeom prst="roundRect">
+            <a:avLst>
+              <a:gd name="adj" fmla="val 4000"/>
+            </a:avLst>
+          </a:prstGeom>
+          <a:solidFill>
+            <a:srgbClr val="F4F0FB"/>
+          </a:solidFill>
+          <a:ln>
+            <a:noFill/>
+          </a:ln>
+          <a:effectLst>
+            <a:outerShdw sx="100000" sy="100000" kx="0" ky="0" algn="bl" rotWithShape="0" blurRad="76200" dist="25400" dir="5400000">
+              <a:srgbClr val="8A78A8">
+                <a:alpha val="28000"/>
+              </a:srgbClr>
+            </a:outerShdw>
+          </a:effectLst>
+        </p:spPr>
+        <p:style>
+          <a:lnRef idx="1">
+            <a:schemeClr val="accent1"/>
+          </a:lnRef>
+          <a:fillRef idx="3">
+            <a:schemeClr val="accent1"/>
+          </a:fillRef>
+          <a:effectRef idx="2">
+            <a:schemeClr val="accent1"/>
+          </a:effectRef>
+          <a:fontRef idx="minor">
+            <a:schemeClr val="lt1"/>
+          </a:fontRef>
+        </p:style>
+        <p:txBody>
+          <a:bodyPr rtlCol="0" anchor="ctr"/>
+          <a:lstStyle/>
+          <a:p>
+            <a:pPr algn="ctr"/>
+          </a:p>
+        </p:txBody>
+      </p:sp>
+      <p:pic>
+        <p:nvPicPr>
+          <p:cNvPr id="11" name="Picture 10" descr="shot_manage_members.png"/>
+          <p:cNvPicPr>
+            <a:picLocks noChangeAspect="1"/>
+          </p:cNvPicPr>
+          <p:nvPr/>
+        </p:nvPicPr>
+        <p:blipFill>
+          <a:blip r:embed="rId4"/>
+          <a:stretch>
+            <a:fillRect/>
+          </a:stretch>
+        </p:blipFill>
+        <p:spPr>
+          <a:xfrm>
+            <a:off x="8234476" y="1645920"/>
+            <a:ext cx="3271418" cy="1908763"/>
+          </a:xfrm>
+          <a:prstGeom prst="rect">
+            <a:avLst/>
+          </a:prstGeom>
+        </p:spPr>
+      </p:pic>
+      <p:sp>
+        <p:nvSpPr>
+          <p:cNvPr id="12" name="TextBox 11"/>
+          <p:cNvSpPr txBox="1"/>
+          <p:nvPr/>
+        </p:nvSpPr>
+        <p:spPr>
+          <a:xfrm>
+            <a:off x="8097316" y="3753612"/>
+            <a:ext cx="3545738" cy="292608"/>
+          </a:xfrm>
+          <a:prstGeom prst="rect">
+            <a:avLst/>
+          </a:prstGeom>
+          <a:noFill/>
+        </p:spPr>
+        <p:txBody>
+          <a:bodyPr wrap="none" lIns="0" rIns="0" tIns="0" bIns="0" anchor="ctr">
+            <a:spAutoFit/>
+          </a:bodyPr>
+          <a:lstStyle/>
+          <a:p>
+            <a:pPr algn="ctr"/>
+            <a:r>
+              <a:rPr sz="1050" b="1">
+                <a:solidFill>
+                  <a:srgbClr val="5E2CA5"/>
+                </a:solidFill>
+                <a:latin typeface="Calibri"/>
+              </a:rPr>
+              <a:t>MANAGE MEMBERS</a:t>
+            </a:r>
+          </a:p>
+        </p:txBody>
+      </p:sp>
+      <p:sp>
+        <p:nvSpPr>
+          <p:cNvPr id="13" name="Rounded Rectangle 12"/>
+          <p:cNvSpPr/>
+          <p:nvPr/>
+        </p:nvSpPr>
+        <p:spPr>
+          <a:xfrm>
+            <a:off x="548640" y="4091939"/>
+            <a:ext cx="3545738" cy="2528316"/>
+          </a:xfrm>
+          <a:prstGeom prst="roundRect">
+            <a:avLst>
+              <a:gd name="adj" fmla="val 4000"/>
+            </a:avLst>
+          </a:prstGeom>
+          <a:solidFill>
+            <a:srgbClr val="F4F0FB"/>
+          </a:solidFill>
+          <a:ln>
+            <a:noFill/>
+          </a:ln>
+          <a:effectLst>
+            <a:outerShdw sx="100000" sy="100000" kx="0" ky="0" algn="bl" rotWithShape="0" blurRad="76200" dist="25400" dir="5400000">
+              <a:srgbClr val="8A78A8">
+                <a:alpha val="28000"/>
+              </a:srgbClr>
+            </a:outerShdw>
+          </a:effectLst>
+        </p:spPr>
+        <p:style>
+          <a:lnRef idx="1">
+            <a:schemeClr val="accent1"/>
+          </a:lnRef>
+          <a:fillRef idx="3">
+            <a:schemeClr val="accent1"/>
+          </a:fillRef>
+          <a:effectRef idx="2">
+            <a:schemeClr val="accent1"/>
+          </a:effectRef>
+          <a:fontRef idx="minor">
+            <a:schemeClr val="lt1"/>
+          </a:fontRef>
+        </p:style>
+        <p:txBody>
+          <a:bodyPr rtlCol="0" anchor="ctr"/>
+          <a:lstStyle/>
+          <a:p>
+            <a:pPr algn="ctr"/>
+          </a:p>
+        </p:txBody>
+      </p:sp>
+      <p:pic>
+        <p:nvPicPr>
+          <p:cNvPr id="14" name="Picture 13" descr="shot_register_member.png"/>
+          <p:cNvPicPr>
+            <a:picLocks noChangeAspect="1"/>
+          </p:cNvPicPr>
+          <p:nvPr/>
+        </p:nvPicPr>
+        <p:blipFill>
+          <a:blip r:embed="rId5"/>
+          <a:stretch>
+            <a:fillRect/>
+          </a:stretch>
+        </p:blipFill>
+        <p:spPr>
+          <a:xfrm>
+            <a:off x="1245449" y="4229100"/>
+            <a:ext cx="2152119" cy="2034540"/>
+          </a:xfrm>
+          <a:prstGeom prst="rect">
+            <a:avLst/>
+          </a:prstGeom>
+        </p:spPr>
+      </p:pic>
+      <p:sp>
+        <p:nvSpPr>
+          <p:cNvPr id="15" name="TextBox 14"/>
+          <p:cNvSpPr txBox="1"/>
+          <p:nvPr/>
+        </p:nvSpPr>
+        <p:spPr>
+          <a:xfrm>
+            <a:off x="548640" y="6336792"/>
+            <a:ext cx="3545738" cy="292608"/>
+          </a:xfrm>
+          <a:prstGeom prst="rect">
+            <a:avLst/>
+          </a:prstGeom>
+          <a:noFill/>
+        </p:spPr>
+        <p:txBody>
+          <a:bodyPr wrap="none" lIns="0" rIns="0" tIns="0" bIns="0" anchor="ctr">
+            <a:spAutoFit/>
+          </a:bodyPr>
+          <a:lstStyle/>
+          <a:p>
+            <a:pPr algn="ctr"/>
+            <a:r>
+              <a:rPr sz="1050" b="1">
+                <a:solidFill>
+                  <a:srgbClr val="5E2CA5"/>
+                </a:solidFill>
+                <a:latin typeface="Calibri"/>
+              </a:rPr>
+              <a:t>REGISTER MEMBER</a:t>
+            </a:r>
+          </a:p>
+        </p:txBody>
+      </p:sp>
+      <p:sp>
+        <p:nvSpPr>
+          <p:cNvPr id="16" name="Rounded Rectangle 15"/>
+          <p:cNvSpPr/>
+          <p:nvPr/>
+        </p:nvSpPr>
+        <p:spPr>
+          <a:xfrm>
+            <a:off x="4322978" y="4091939"/>
+            <a:ext cx="3545738" cy="2528316"/>
+          </a:xfrm>
+          <a:prstGeom prst="roundRect">
+            <a:avLst>
+              <a:gd name="adj" fmla="val 4000"/>
+            </a:avLst>
+          </a:prstGeom>
+          <a:solidFill>
+            <a:srgbClr val="F4F0FB"/>
+          </a:solidFill>
+          <a:ln>
+            <a:noFill/>
+          </a:ln>
+          <a:effectLst>
+            <a:outerShdw sx="100000" sy="100000" kx="0" ky="0" algn="bl" rotWithShape="0" blurRad="76200" dist="25400" dir="5400000">
+              <a:srgbClr val="8A78A8">
+                <a:alpha val="28000"/>
+              </a:srgbClr>
+            </a:outerShdw>
+          </a:effectLst>
+        </p:spPr>
+        <p:style>
+          <a:lnRef idx="1">
+            <a:schemeClr val="accent1"/>
+          </a:lnRef>
+          <a:fillRef idx="3">
+            <a:schemeClr val="accent1"/>
+          </a:fillRef>
+          <a:effectRef idx="2">
+            <a:schemeClr val="accent1"/>
+          </a:effectRef>
+          <a:fontRef idx="minor">
+            <a:schemeClr val="lt1"/>
+          </a:fontRef>
+        </p:style>
+        <p:txBody>
+          <a:bodyPr rtlCol="0" anchor="ctr"/>
+          <a:lstStyle/>
+          <a:p>
+            <a:pPr algn="ctr"/>
+          </a:p>
+        </p:txBody>
+      </p:sp>
+      <p:pic>
+        <p:nvPicPr>
+          <p:cNvPr id="17" name="Picture 16" descr="shot_reports.png"/>
+          <p:cNvPicPr>
+            <a:picLocks noChangeAspect="1"/>
+          </p:cNvPicPr>
+          <p:nvPr/>
+        </p:nvPicPr>
+        <p:blipFill>
+          <a:blip r:embed="rId6"/>
+          <a:stretch>
+            <a:fillRect/>
+          </a:stretch>
+        </p:blipFill>
+        <p:spPr>
+          <a:xfrm>
+            <a:off x="4823012" y="4229100"/>
+            <a:ext cx="2545670" cy="2034540"/>
+          </a:xfrm>
+          <a:prstGeom prst="rect">
+            <a:avLst/>
+          </a:prstGeom>
+        </p:spPr>
+      </p:pic>
+      <p:sp>
+        <p:nvSpPr>
+          <p:cNvPr id="18" name="TextBox 17"/>
+          <p:cNvSpPr txBox="1"/>
+          <p:nvPr/>
+        </p:nvSpPr>
+        <p:spPr>
+          <a:xfrm>
+            <a:off x="4322978" y="6336792"/>
+            <a:ext cx="3545738" cy="292608"/>
+          </a:xfrm>
+          <a:prstGeom prst="rect">
+            <a:avLst/>
+          </a:prstGeom>
+          <a:noFill/>
+        </p:spPr>
+        <p:txBody>
+          <a:bodyPr wrap="none" lIns="0" rIns="0" tIns="0" bIns="0" anchor="ctr">
+            <a:spAutoFit/>
+          </a:bodyPr>
+          <a:lstStyle/>
+          <a:p>
+            <a:pPr algn="ctr"/>
+            <a:r>
+              <a:rPr sz="1050" b="1">
+                <a:solidFill>
+                  <a:srgbClr val="5E2CA5"/>
+                </a:solidFill>
+                <a:latin typeface="Calibri"/>
+              </a:rPr>
+              <a:t>OPERATIONAL REPORTS</a:t>
+            </a:r>
+          </a:p>
+        </p:txBody>
+      </p:sp>
+      <p:sp>
+        <p:nvSpPr>
+          <p:cNvPr id="19" name="Rounded Rectangle 18"/>
+          <p:cNvSpPr/>
+          <p:nvPr/>
+        </p:nvSpPr>
+        <p:spPr>
+          <a:xfrm>
+            <a:off x="8097316" y="4091939"/>
+            <a:ext cx="3545738" cy="2528316"/>
+          </a:xfrm>
+          <a:prstGeom prst="roundRect">
+            <a:avLst>
+              <a:gd name="adj" fmla="val 4000"/>
+            </a:avLst>
+          </a:prstGeom>
+          <a:solidFill>
+            <a:srgbClr val="F4F0FB"/>
+          </a:solidFill>
+          <a:ln>
+            <a:noFill/>
+          </a:ln>
+          <a:effectLst>
+            <a:outerShdw sx="100000" sy="100000" kx="0" ky="0" algn="bl" rotWithShape="0" blurRad="76200" dist="25400" dir="5400000">
+              <a:srgbClr val="8A78A8">
+                <a:alpha val="28000"/>
+              </a:srgbClr>
+            </a:outerShdw>
+          </a:effectLst>
+        </p:spPr>
+        <p:style>
+          <a:lnRef idx="1">
+            <a:schemeClr val="accent1"/>
+          </a:lnRef>
+          <a:fillRef idx="3">
+            <a:schemeClr val="accent1"/>
+          </a:fillRef>
+          <a:effectRef idx="2">
+            <a:schemeClr val="accent1"/>
+          </a:effectRef>
+          <a:fontRef idx="minor">
+            <a:schemeClr val="lt1"/>
+          </a:fontRef>
+        </p:style>
+        <p:txBody>
+          <a:bodyPr rtlCol="0" anchor="ctr"/>
+          <a:lstStyle/>
+          <a:p>
+            <a:pPr algn="ctr"/>
+          </a:p>
+        </p:txBody>
+      </p:sp>
+      <p:pic>
+        <p:nvPicPr>
+          <p:cNvPr id="20" name="Picture 19" descr="shot_payments_history.png"/>
+          <p:cNvPicPr>
+            <a:picLocks noChangeAspect="1"/>
+          </p:cNvPicPr>
+          <p:nvPr/>
+        </p:nvPicPr>
+        <p:blipFill>
+          <a:blip r:embed="rId7"/>
+          <a:stretch>
+            <a:fillRect/>
+          </a:stretch>
+        </p:blipFill>
+        <p:spPr>
+          <a:xfrm>
+            <a:off x="8272902" y="4229100"/>
+            <a:ext cx="3194567" cy="2034540"/>
+          </a:xfrm>
+          <a:prstGeom prst="rect">
+            <a:avLst/>
+          </a:prstGeom>
+        </p:spPr>
+      </p:pic>
+      <p:sp>
+        <p:nvSpPr>
+          <p:cNvPr id="21" name="TextBox 20"/>
+          <p:cNvSpPr txBox="1"/>
+          <p:nvPr/>
+        </p:nvSpPr>
+        <p:spPr>
+          <a:xfrm>
+            <a:off x="8097316" y="6336792"/>
+            <a:ext cx="3545738" cy="292608"/>
+          </a:xfrm>
+          <a:prstGeom prst="rect">
+            <a:avLst/>
+          </a:prstGeom>
+          <a:noFill/>
+        </p:spPr>
+        <p:txBody>
+          <a:bodyPr wrap="none" lIns="0" rIns="0" tIns="0" bIns="0" anchor="ctr">
+            <a:spAutoFit/>
+          </a:bodyPr>
+          <a:lstStyle/>
+          <a:p>
+            <a:pPr algn="ctr"/>
+            <a:r>
+              <a:rPr sz="1050" b="1">
+                <a:solidFill>
+                  <a:srgbClr val="5E2CA5"/>
+                </a:solidFill>
+                <a:latin typeface="Calibri"/>
+              </a:rPr>
+              <a:t>PAYMENT HISTORY</a:t>
+            </a:r>
+          </a:p>
+        </p:txBody>
+      </p:sp>
+    </p:spTree>
+  </p:cSld>
+  <p:clrMapOvr>
+    <a:masterClrMapping/>
+  </p:clrMapOvr>
+</p:sld>
+</file>
+
 <file path=ppt/slides/slide2.xml><?xml version="1.0" encoding="utf-8"?>
 <p:sld xmlns:a="http://schemas.openxmlformats.org/drawingml/2006/main" xmlns:r="http://schemas.openxmlformats.org/officeDocument/2006/relationships" xmlns:p="http://schemas.openxmlformats.org/presentationml/2006/main">
   <p:cSld name="Slide 2">

</xml_diff>